<commit_message>
feat(presentation): 표지 팀명·팀원 명세 (#82)
- 슬라이드 1 표지: 팀명 편돌이들 + 팀장 이정주 / 부팀장 백승환 /
  팀원 오세울·문규승 두 줄로 명세 (13pt 팀명·11pt 멤버 위계)
- 스피커 노트: "안녕하세요, 편돌이들 팀입니다" 로 갱신
- PPTX 메타 author "Fitly Team" → "편돌이들"
</commit_message>
<xml_diff>
--- a/fitly/발표.pptx
+++ b/fitly/발표.pptx
@@ -515,7 +515,7 @@
           <a:p>
             <a:r>
               <a:rPr lang="en-US" dirty="0"/>
-              <a:t>안녕하세요, [팀명] 입니다. 저희가 만든 Fitly 를 소개해 드리겠습니다.</a:t>
+              <a:t>안녕하세요, 편돌이들 팀입니다. 저희가 만든 Fitly 를 소개해 드리겠습니다.</a:t>
             </a:r>
             <a:endParaRPr lang="en-US" dirty="0"/>
           </a:p>
@@ -7049,7 +7049,7 @@
         <p:spPr>
           <a:xfrm>
             <a:off x="457200" y="3200400"/>
-            <a:ext cx="8229600" cy="1371600"/>
+            <a:ext cx="8229600" cy="1463040"/>
           </a:xfrm>
           <a:prstGeom prst="rect">
             <a:avLst/>
@@ -7096,7 +7096,7 @@
               <a:buNone/>
             </a:pPr>
             <a:r>
-              <a:rPr lang="en-US" sz="1200" dirty="0">
+              <a:rPr lang="en-US" sz="1300" dirty="0">
                 <a:solidFill>
                   <a:srgbClr val="6B6256"/>
                 </a:solidFill>
@@ -7104,7 +7104,136 @@
                 <a:ea typeface="Noto Sans KR" pitchFamily="34" charset="-122"/>
                 <a:cs typeface="Noto Sans KR" pitchFamily="34" charset="-120"/>
               </a:rPr>
-              <a:t>팀명: [팀명]   ·   2026.05</a:t>
+              <a:t>팀명 </a:t>
+            </a:r>
+            <a:pPr algn="ctr" indent="0" marL="0">
+              <a:buNone/>
+            </a:pPr>
+            <a:r>
+              <a:rPr lang="en-US" sz="1300" b="1" dirty="0">
+                <a:solidFill>
+                  <a:srgbClr val="1A2027"/>
+                </a:solidFill>
+                <a:latin typeface="Noto Sans KR" pitchFamily="34" charset="0"/>
+                <a:ea typeface="Noto Sans KR" pitchFamily="34" charset="-122"/>
+                <a:cs typeface="Noto Sans KR" pitchFamily="34" charset="-120"/>
+              </a:rPr>
+              <a:t>편돌이들</a:t>
+            </a:r>
+            <a:pPr algn="ctr" indent="0" marL="0">
+              <a:buNone/>
+            </a:pPr>
+            <a:r>
+              <a:rPr lang="en-US" sz="1300" dirty="0">
+                <a:solidFill>
+                  <a:srgbClr val="6B6256"/>
+                </a:solidFill>
+                <a:latin typeface="Noto Sans KR" pitchFamily="34" charset="0"/>
+                <a:ea typeface="Noto Sans KR" pitchFamily="34" charset="-122"/>
+                <a:cs typeface="Noto Sans KR" pitchFamily="34" charset="-120"/>
+              </a:rPr>
+              <a:t>   ·   2026.05</a:t>
+            </a:r>
+            <a:endParaRPr lang="en-US" sz="1400" dirty="0"/>
+          </a:p>
+          <a:p>
+            <a:pPr algn="ctr" indent="0" marL="0">
+              <a:buNone/>
+            </a:pPr>
+            <a:r>
+              <a:rPr lang="en-US" sz="400" dirty="0">
+                <a:solidFill>
+                  <a:srgbClr val="000000"/>
+                </a:solidFill>
+              </a:rPr>
+              <a:t> </a:t>
+            </a:r>
+            <a:endParaRPr lang="en-US" sz="1400" dirty="0"/>
+          </a:p>
+          <a:p>
+            <a:pPr algn="ctr" indent="0" marL="0">
+              <a:buNone/>
+            </a:pPr>
+            <a:r>
+              <a:rPr lang="en-US" sz="1100" dirty="0">
+                <a:solidFill>
+                  <a:srgbClr val="6B6256"/>
+                </a:solidFill>
+                <a:latin typeface="Noto Sans KR" pitchFamily="34" charset="0"/>
+                <a:ea typeface="Noto Sans KR" pitchFamily="34" charset="-122"/>
+                <a:cs typeface="Noto Sans KR" pitchFamily="34" charset="-120"/>
+              </a:rPr>
+              <a:t>팀장 </a:t>
+            </a:r>
+            <a:pPr algn="ctr" indent="0" marL="0">
+              <a:buNone/>
+            </a:pPr>
+            <a:r>
+              <a:rPr lang="en-US" sz="1100" dirty="0">
+                <a:solidFill>
+                  <a:srgbClr val="1A2027"/>
+                </a:solidFill>
+                <a:latin typeface="Noto Sans KR" pitchFamily="34" charset="0"/>
+                <a:ea typeface="Noto Sans KR" pitchFamily="34" charset="-122"/>
+                <a:cs typeface="Noto Sans KR" pitchFamily="34" charset="-120"/>
+              </a:rPr>
+              <a:t>이정주</a:t>
+            </a:r>
+            <a:pPr algn="ctr" indent="0" marL="0">
+              <a:buNone/>
+            </a:pPr>
+            <a:r>
+              <a:rPr lang="en-US" sz="1100" dirty="0">
+                <a:solidFill>
+                  <a:srgbClr val="6B6256"/>
+                </a:solidFill>
+                <a:latin typeface="Noto Sans KR" pitchFamily="34" charset="0"/>
+                <a:ea typeface="Noto Sans KR" pitchFamily="34" charset="-122"/>
+                <a:cs typeface="Noto Sans KR" pitchFamily="34" charset="-120"/>
+              </a:rPr>
+              <a:t>   ·   부팀장 </a:t>
+            </a:r>
+            <a:pPr algn="ctr" indent="0" marL="0">
+              <a:buNone/>
+            </a:pPr>
+            <a:r>
+              <a:rPr lang="en-US" sz="1100" dirty="0">
+                <a:solidFill>
+                  <a:srgbClr val="1A2027"/>
+                </a:solidFill>
+                <a:latin typeface="Noto Sans KR" pitchFamily="34" charset="0"/>
+                <a:ea typeface="Noto Sans KR" pitchFamily="34" charset="-122"/>
+                <a:cs typeface="Noto Sans KR" pitchFamily="34" charset="-120"/>
+              </a:rPr>
+              <a:t>백승환</a:t>
+            </a:r>
+            <a:pPr algn="ctr" indent="0" marL="0">
+              <a:buNone/>
+            </a:pPr>
+            <a:r>
+              <a:rPr lang="en-US" sz="1100" dirty="0">
+                <a:solidFill>
+                  <a:srgbClr val="6B6256"/>
+                </a:solidFill>
+                <a:latin typeface="Noto Sans KR" pitchFamily="34" charset="0"/>
+                <a:ea typeface="Noto Sans KR" pitchFamily="34" charset="-122"/>
+                <a:cs typeface="Noto Sans KR" pitchFamily="34" charset="-120"/>
+              </a:rPr>
+              <a:t>   ·   팀원 </a:t>
+            </a:r>
+            <a:pPr algn="ctr" indent="0" marL="0">
+              <a:buNone/>
+            </a:pPr>
+            <a:r>
+              <a:rPr lang="en-US" sz="1100" dirty="0">
+                <a:solidFill>
+                  <a:srgbClr val="1A2027"/>
+                </a:solidFill>
+                <a:latin typeface="Noto Sans KR" pitchFamily="34" charset="0"/>
+                <a:ea typeface="Noto Sans KR" pitchFamily="34" charset="-122"/>
+                <a:cs typeface="Noto Sans KR" pitchFamily="34" charset="-120"/>
+              </a:rPr>
+              <a:t>오세울, 문규승</a:t>
             </a:r>
             <a:endParaRPr lang="en-US" sz="1400" dirty="0"/>
           </a:p>

</xml_diff>